<commit_message>
add lab8 for vivado
</commit_message>
<xml_diff>
--- a/tutorials/lab0_虚拟机.pptx
+++ b/tutorials/lab0_虚拟机.pptx
@@ -251,7 +251,7 @@
           <a:p>
             <a:fld id="{9ED75E01-0EF1-48C2-A225-423E6166D74A}" type="datetimeFigureOut">
               <a:rPr lang="zh-CN" altLang="en-US" smtClean="0"/>
-              <a:t>2024/9/29</a:t>
+              <a:t>2025/11/13</a:t>
             </a:fld>
             <a:endParaRPr lang="zh-CN" altLang="en-US"/>
           </a:p>
@@ -1259,7 +1259,7 @@
           <a:p>
             <a:fld id="{525738E0-514B-4B27-865A-11992516E93C}" type="datetime4">
               <a:rPr lang="en-US" altLang="zh-CN" smtClean="0"/>
-              <a:t>September 29, 2024</a:t>
+              <a:t>November 13, 2025</a:t>
             </a:fld>
             <a:endParaRPr lang="zh-CN" altLang="en-US"/>
           </a:p>
@@ -3135,7 +3135,7 @@
           <a:p>
             <a:fld id="{FB5C3CA1-B04C-4C04-8D1E-77CF30B3E24E}" type="datetime1">
               <a:rPr lang="en-US" altLang="zh-CN" smtClean="0"/>
-              <a:t>9/29/2024</a:t>
+              <a:t>11/13/2025</a:t>
             </a:fld>
             <a:endParaRPr lang="en-US"/>
           </a:p>
@@ -4420,7 +4420,7 @@
             </a:pPr>
             <a:fld id="{0E0D492D-E599-4F0D-BA78-6EEA0311D34C}" type="datetime4">
               <a:rPr lang="en-US" altLang="zh-CN" smtClean="0"/>
-              <a:t>September 29, 2024</a:t>
+              <a:t>November 13, 2025</a:t>
             </a:fld>
             <a:endParaRPr lang="en-US" altLang="zh-CN">
               <a:cs typeface="Arial" charset="0"/>
@@ -4729,7 +4729,7 @@
             </a:pPr>
             <a:fld id="{D67BBE8C-0A4B-43CE-9430-1242DFAA7339}" type="datetime4">
               <a:rPr lang="en-US" altLang="zh-CN" smtClean="0"/>
-              <a:t>September 29, 2024</a:t>
+              <a:t>November 13, 2025</a:t>
             </a:fld>
             <a:endParaRPr lang="en-US" altLang="zh-CN">
               <a:cs typeface="Arial" charset="0"/>
@@ -4870,7 +4870,7 @@
             </a:pPr>
             <a:fld id="{4E341A39-4A90-477E-8107-2FD1A1C95399}" type="datetime4">
               <a:rPr lang="en-US" altLang="zh-CN" smtClean="0"/>
-              <a:t>September 29, 2024</a:t>
+              <a:t>November 13, 2025</a:t>
             </a:fld>
             <a:endParaRPr lang="en-US" altLang="zh-CN">
               <a:cs typeface="Arial" charset="0"/>
@@ -5175,7 +5175,7 @@
             </a:pPr>
             <a:fld id="{0629EA72-D578-4F57-BEAD-86CF28FC678C}" type="datetime4">
               <a:rPr lang="en-US" altLang="zh-CN" smtClean="0"/>
-              <a:t>September 29, 2024</a:t>
+              <a:t>November 13, 2025</a:t>
             </a:fld>
             <a:endParaRPr lang="en-US" altLang="zh-CN">
               <a:cs typeface="Arial" charset="0"/>
@@ -5967,7 +5967,6 @@
             <a:noFill/>
           </a:ln>
           <a:effectLst/>
-          <a:extLst/>
         </p:spPr>
         <p:txBody>
           <a:bodyPr vert="horz" wrap="square" lIns="91440" tIns="45720" rIns="91440" bIns="45720" numCol="1" anchor="b" anchorCtr="0" compatLnSpc="1">
@@ -6014,7 +6013,6 @@
             <a:noFill/>
           </a:ln>
           <a:effectLst/>
-          <a:extLst/>
         </p:spPr>
         <p:txBody>
           <a:bodyPr vert="horz" wrap="square" lIns="91440" tIns="45720" rIns="91440" bIns="45720" numCol="1" anchor="b" anchorCtr="0" compatLnSpc="1">
@@ -6611,7 +6609,6 @@
             <a:noFill/>
           </a:ln>
           <a:effectLst/>
-          <a:extLst/>
         </p:spPr>
         <p:txBody>
           <a:bodyPr vert="horz" wrap="square" lIns="91440" tIns="45720" rIns="91440" bIns="45720" numCol="1" anchor="b" anchorCtr="0" compatLnSpc="1">
@@ -6633,7 +6630,7 @@
             </a:pPr>
             <a:fld id="{D6C2F118-23C6-4D76-A422-251B03B97126}" type="datetime4">
               <a:rPr lang="en-US" altLang="zh-CN" smtClean="0"/>
-              <a:t>September 29, 2024</a:t>
+              <a:t>November 13, 2025</a:t>
             </a:fld>
             <a:endParaRPr lang="en-US" altLang="zh-CN">
               <a:cs typeface="Arial" charset="0"/>
@@ -7170,7 +7167,7 @@
           <a:p>
             <a:r>
               <a:rPr lang="en-US" altLang="zh-CN" sz="2800" dirty="0"/>
-              <a:t>2024</a:t>
+              <a:t>2025</a:t>
             </a:r>
             <a:r>
               <a:rPr lang="zh-CN" altLang="en-US" sz="2800" dirty="0"/>
@@ -7178,7 +7175,7 @@
             </a:r>
             <a:r>
               <a:rPr lang="en-US" altLang="zh-CN" sz="2800" dirty="0"/>
-              <a:t>9</a:t>
+              <a:t>11</a:t>
             </a:r>
             <a:r>
               <a:rPr lang="zh-CN" altLang="en-US" sz="2800" dirty="0"/>
@@ -7186,7 +7183,7 @@
             </a:r>
             <a:r>
               <a:rPr lang="en-US" altLang="zh-CN" sz="2800" dirty="0"/>
-              <a:t>20</a:t>
+              <a:t>13</a:t>
             </a:r>
             <a:r>
               <a:rPr lang="zh-CN" altLang="en-US" sz="2800" dirty="0"/>
@@ -7283,6 +7280,37 @@
         <p:txBody>
           <a:bodyPr/>
           <a:lstStyle/>
+          <a:p>
+            <a:r>
+              <a:rPr lang="zh-CN" altLang="en-US" dirty="0"/>
+              <a:t>升级</a:t>
+            </a:r>
+            <a:r>
+              <a:rPr lang="en-US" altLang="zh-CN" dirty="0" err="1"/>
+              <a:t>cocotb</a:t>
+            </a:r>
+            <a:r>
+              <a:rPr lang="zh-CN" altLang="en-US" dirty="0"/>
+              <a:t>的版本至</a:t>
+            </a:r>
+            <a:r>
+              <a:rPr lang="en-US" altLang="zh-CN"/>
+              <a:t>2.0</a:t>
+            </a:r>
+            <a:endParaRPr lang="en-US" altLang="zh-CN" dirty="0"/>
+          </a:p>
+          <a:p>
+            <a:pPr lvl="1"/>
+            <a:r>
+              <a:rPr lang="en-US" altLang="zh-CN" dirty="0"/>
+              <a:t>pip install –upgrade </a:t>
+            </a:r>
+            <a:r>
+              <a:rPr lang="en-US" altLang="zh-CN" dirty="0" err="1"/>
+              <a:t>cocotb</a:t>
+            </a:r>
+            <a:endParaRPr lang="en-US" altLang="zh-CN" dirty="0"/>
+          </a:p>
           <a:p>
             <a:r>
               <a:rPr lang="en-US" altLang="zh-CN" dirty="0"/>
@@ -7834,16 +7862,12 @@
           </a:p>
           <a:p>
             <a:r>
+              <a:rPr lang="en-US" altLang="zh-CN" dirty="0"/>
+              <a:t>Ubuntu22</a:t>
+            </a:r>
+            <a:r>
               <a:rPr lang="zh-CN" altLang="en-US" dirty="0"/>
-              <a:t>从复旦云盘下载虚拟机、</a:t>
-            </a:r>
-            <a:r>
-              <a:rPr lang="en-US" altLang="zh-CN" dirty="0" err="1"/>
-              <a:t>vmware</a:t>
-            </a:r>
-            <a:r>
-              <a:rPr lang="zh-CN" altLang="en-US" dirty="0"/>
-              <a:t>安装文件等工具</a:t>
+              <a:t>虚拟机（可选）</a:t>
             </a:r>
             <a:endParaRPr lang="en-US" altLang="zh-CN" dirty="0"/>
           </a:p>
@@ -7894,9 +7918,18 @@
             </a:r>
           </a:p>
           <a:p>
+            <a:pPr lvl="1"/>
             <a:r>
               <a:rPr lang="zh-CN" altLang="en-US" dirty="0"/>
-              <a:t>安装虚拟机软件（</a:t>
+              <a:t>安装虚拟机软件</a:t>
+            </a:r>
+            <a:r>
+              <a:rPr lang="en-US" altLang="zh-CN" dirty="0"/>
+              <a:t>VMwareWorkstationPro_V17.5.2.23775571.exe</a:t>
+            </a:r>
+            <a:r>
+              <a:rPr lang="zh-CN" altLang="en-US" dirty="0"/>
+              <a:t>（</a:t>
             </a:r>
             <a:r>
               <a:rPr lang="en-US" altLang="zh-CN" dirty="0" err="1"/>
@@ -7909,13 +7942,6 @@
             <a:r>
               <a:rPr lang="en-US" altLang="zh-CN" dirty="0"/>
               <a:t>license</a:t>
-            </a:r>
-          </a:p>
-          <a:p>
-            <a:pPr lvl="1"/>
-            <a:r>
-              <a:rPr lang="en-US" altLang="zh-CN" dirty="0"/>
-              <a:t>VMwareWorkstationPro_V17.5.2.23775571.exe</a:t>
             </a:r>
           </a:p>
           <a:p>
@@ -11257,7 +11283,51 @@
           <a:bodyPr/>
           <a:lstStyle/>
           <a:p>
+            <a:r>
+              <a:rPr lang="zh-CN" altLang="en-US" dirty="0"/>
+              <a:t>方案</a:t>
+            </a:r>
+            <a:r>
+              <a:rPr lang="en-US" altLang="zh-CN" dirty="0"/>
+              <a:t>1</a:t>
+            </a:r>
+          </a:p>
+          <a:p>
+            <a:pPr lvl="1"/>
+            <a:r>
+              <a:rPr lang="zh-CN" altLang="en-US" dirty="0"/>
+              <a:t>安装</a:t>
+            </a:r>
+            <a:r>
+              <a:rPr lang="en-US" altLang="zh-CN" dirty="0"/>
+              <a:t>Watt Toolkit</a:t>
+            </a:r>
+            <a:r>
+              <a:rPr lang="zh-CN" altLang="en-US" dirty="0"/>
+              <a:t>，配置</a:t>
+            </a:r>
+            <a:r>
+              <a:rPr lang="en-US" altLang="zh-CN" dirty="0" err="1"/>
+              <a:t>gtihub</a:t>
+            </a:r>
+            <a:r>
+              <a:rPr lang="zh-CN" altLang="en-US" dirty="0"/>
+              <a:t>加速</a:t>
+            </a:r>
             <a:endParaRPr lang="en-US" altLang="zh-CN" dirty="0"/>
+          </a:p>
+          <a:p>
+            <a:endParaRPr lang="en-US" altLang="zh-CN" dirty="0"/>
+          </a:p>
+          <a:p>
+            <a:r>
+              <a:rPr lang="zh-CN" altLang="en-US" dirty="0"/>
+              <a:t>方案</a:t>
+            </a:r>
+            <a:r>
+              <a:rPr lang="en-US" altLang="zh-CN" dirty="0"/>
+              <a:t>2</a:t>
+            </a:r>
           </a:p>
           <a:p>
             <a:pPr lvl="1"/>
@@ -12199,7 +12269,7 @@
         <a:sysClr val="windowText" lastClr="000000"/>
       </a:dk1>
       <a:lt1>
-        <a:sysClr val="window" lastClr="CEEACA"/>
+        <a:sysClr val="window" lastClr="CCEDC7"/>
       </a:lt1>
       <a:dk2>
         <a:srgbClr val="1F497D"/>

</xml_diff>